<commit_message>
More updated version of our task
</commit_message>
<xml_diff>
--- a/TASK 3/Group16 Task 3.pptx
+++ b/TASK 3/Group16 Task 3.pptx
@@ -1748,7 +1748,9 @@
     <p:bg>
       <p:bgPr>
         <a:solidFill>
-          <a:srgbClr val="0A2342"/>
+          <a:schemeClr val="bg1">
+            <a:lumMod val="85000"/>
+          </a:schemeClr>
         </a:solidFill>
         <a:effectLst/>
       </p:bgPr>
@@ -1843,20 +1845,13 @@
             </a:pPr>
             <a:r>
               <a:rPr lang="en-US" sz="2400" b="1" kern="0" spc="300" dirty="0">
-                <a:solidFill>
-                  <a:schemeClr val="bg1"/>
-                </a:solidFill>
                 <a:latin typeface="Calibri" pitchFamily="34" charset="0"/>
                 <a:ea typeface="Calibri" pitchFamily="34" charset="-122"/>
                 <a:cs typeface="Calibri" pitchFamily="34" charset="-120"/>
               </a:rPr>
               <a:t>UNIVERSITY OF BUEA</a:t>
             </a:r>
-            <a:endParaRPr lang="en-US" sz="2400" dirty="0">
-              <a:solidFill>
-                <a:schemeClr val="bg1"/>
-              </a:solidFill>
-            </a:endParaRPr>
+            <a:endParaRPr lang="en-US" sz="2400" dirty="0"/>
           </a:p>
         </p:txBody>
       </p:sp>
@@ -1886,9 +1881,6 @@
             </a:pPr>
             <a:r>
               <a:rPr lang="en-US" sz="2000" dirty="0">
-                <a:solidFill>
-                  <a:schemeClr val="bg1"/>
-                </a:solidFill>
                 <a:latin typeface="Calibri" pitchFamily="34" charset="0"/>
                 <a:ea typeface="Calibri" pitchFamily="34" charset="-122"/>
                 <a:cs typeface="Calibri" pitchFamily="34" charset="-120"/>
@@ -1900,9 +1892,6 @@
             <a:pPr algn="ctr"/>
             <a:r>
               <a:rPr lang="en-US" sz="2000" dirty="0">
-                <a:solidFill>
-                  <a:schemeClr val="bg1"/>
-                </a:solidFill>
                 <a:latin typeface="Calibri" pitchFamily="34" charset="0"/>
                 <a:ea typeface="Calibri" pitchFamily="34" charset="-122"/>
                 <a:cs typeface="Calibri" pitchFamily="34" charset="-120"/>
@@ -1910,11 +1899,7 @@
               <a:t>CEF440 - </a:t>
             </a:r>
             <a:r>
-              <a:rPr lang="en-US" sz="2000" dirty="0">
-                <a:solidFill>
-                  <a:schemeClr val="bg1"/>
-                </a:solidFill>
-              </a:rPr>
+              <a:rPr lang="en-US" sz="2000" dirty="0"/>
               <a:t>INTERNET PROGRAMMING AND MOBILE PROGRAMMING </a:t>
             </a:r>
           </a:p>
@@ -1949,9 +1934,6 @@
             </a:pPr>
             <a:r>
               <a:rPr lang="en-US" sz="5400" b="1" dirty="0">
-                <a:solidFill>
-                  <a:srgbClr val="FFFFFF"/>
-                </a:solidFill>
                 <a:latin typeface="Calibri" pitchFamily="34" charset="0"/>
                 <a:ea typeface="Calibri" pitchFamily="34" charset="-122"/>
                 <a:cs typeface="Calibri" pitchFamily="34" charset="-120"/>
@@ -1969,9 +1951,6 @@
             </a:pPr>
             <a:r>
               <a:rPr lang="en-US" sz="5400" b="1" dirty="0">
-                <a:solidFill>
-                  <a:srgbClr val="FFFFFF"/>
-                </a:solidFill>
                 <a:latin typeface="Calibri" pitchFamily="34" charset="0"/>
                 <a:ea typeface="Calibri" pitchFamily="34" charset="-122"/>
                 <a:cs typeface="Calibri" pitchFamily="34" charset="-120"/>
@@ -2008,20 +1987,13 @@
             </a:pPr>
             <a:r>
               <a:rPr lang="en-US" kern="0" spc="200" dirty="0">
-                <a:solidFill>
-                  <a:schemeClr val="bg1"/>
-                </a:solidFill>
                 <a:latin typeface="Calibri" pitchFamily="34" charset="0"/>
                 <a:ea typeface="Calibri" pitchFamily="34" charset="-122"/>
                 <a:cs typeface="Calibri" pitchFamily="34" charset="-120"/>
               </a:rPr>
               <a:t>GROUP 16 </a:t>
             </a:r>
-            <a:endParaRPr lang="en-US" dirty="0">
-              <a:solidFill>
-                <a:schemeClr val="bg1"/>
-              </a:solidFill>
-            </a:endParaRPr>
+            <a:endParaRPr lang="en-US" dirty="0"/>
           </a:p>
         </p:txBody>
       </p:sp>
@@ -2051,20 +2023,13 @@
             </a:pPr>
             <a:r>
               <a:rPr lang="en-US" dirty="0">
-                <a:solidFill>
-                  <a:schemeClr val="bg1"/>
-                </a:solidFill>
                 <a:latin typeface="Calibri" pitchFamily="34" charset="0"/>
                 <a:ea typeface="Calibri" pitchFamily="34" charset="-122"/>
                 <a:cs typeface="Calibri" pitchFamily="34" charset="-120"/>
               </a:rPr>
               <a:t>Course Instructor: Dr. Nkemeni Valery</a:t>
             </a:r>
-            <a:endParaRPr lang="en-US" dirty="0">
-              <a:solidFill>
-                <a:schemeClr val="bg1"/>
-              </a:solidFill>
-            </a:endParaRPr>
+            <a:endParaRPr lang="en-US" dirty="0"/>
           </a:p>
         </p:txBody>
       </p:sp>
@@ -2316,7 +2281,9 @@
     <p:bg>
       <p:bgPr>
         <a:solidFill>
-          <a:srgbClr val="FFFFFF"/>
+          <a:schemeClr val="bg1">
+            <a:lumMod val="85000"/>
+          </a:schemeClr>
         </a:solidFill>
         <a:effectLst/>
       </p:bgPr>
@@ -4089,7 +4056,9 @@
     <p:bg>
       <p:bgPr>
         <a:solidFill>
-          <a:srgbClr val="FFFFFF"/>
+          <a:schemeClr val="bg1">
+            <a:lumMod val="85000"/>
+          </a:schemeClr>
         </a:solidFill>
         <a:effectLst/>
       </p:bgPr>
@@ -5373,6 +5342,16 @@
 <file path=ppt/slides/slide14.xml><?xml version="1.0" encoding="utf-8"?>
 <p:sld xmlns:a="http://schemas.openxmlformats.org/drawingml/2006/main" xmlns:r="http://schemas.openxmlformats.org/officeDocument/2006/relationships" xmlns:p="http://schemas.openxmlformats.org/presentationml/2006/main">
   <p:cSld>
+    <p:bg>
+      <p:bgPr>
+        <a:solidFill>
+          <a:schemeClr val="bg1">
+            <a:lumMod val="85000"/>
+          </a:schemeClr>
+        </a:solidFill>
+        <a:effectLst/>
+      </p:bgPr>
+    </p:bg>
     <p:spTree>
       <p:nvGrpSpPr>
         <p:cNvPr id="1" name=""/>
@@ -6879,6 +6858,16 @@
 <file path=ppt/slides/slide15.xml><?xml version="1.0" encoding="utf-8"?>
 <p:sld xmlns:a="http://schemas.openxmlformats.org/drawingml/2006/main" xmlns:r="http://schemas.openxmlformats.org/officeDocument/2006/relationships" xmlns:p="http://schemas.openxmlformats.org/presentationml/2006/main">
   <p:cSld>
+    <p:bg>
+      <p:bgPr>
+        <a:solidFill>
+          <a:schemeClr val="bg1">
+            <a:lumMod val="85000"/>
+          </a:schemeClr>
+        </a:solidFill>
+        <a:effectLst/>
+      </p:bgPr>
+    </p:bg>
     <p:spTree>
       <p:nvGrpSpPr>
         <p:cNvPr id="1" name=""/>
@@ -7000,7 +6989,7 @@
               <a:buNone/>
             </a:pPr>
             <a:r>
-              <a:rPr lang="en-US" sz="1400" b="1" kern="0" spc="150" dirty="0">
+              <a:rPr lang="en-US" sz="2000" b="1" kern="0" spc="150" dirty="0">
                 <a:solidFill>
                   <a:srgbClr val="0097A7"/>
                 </a:solidFill>
@@ -7010,7 +6999,7 @@
               </a:rPr>
               <a:t>USE CASES</a:t>
             </a:r>
-            <a:endParaRPr lang="en-US" sz="1400" dirty="0"/>
+            <a:endParaRPr lang="en-US" sz="2000" dirty="0"/>
           </a:p>
         </p:txBody>
       </p:sp>
@@ -7833,7 +7822,7 @@
               <a:buNone/>
             </a:pPr>
             <a:r>
-              <a:rPr lang="en-US" sz="1400" b="1" kern="0" spc="150" dirty="0">
+              <a:rPr lang="en-US" sz="2000" b="1" kern="0" spc="150" dirty="0">
                 <a:solidFill>
                   <a:srgbClr val="1565C0"/>
                 </a:solidFill>
@@ -7843,7 +7832,7 @@
               </a:rPr>
               <a:t>KEY DATA FIELDS</a:t>
             </a:r>
-            <a:endParaRPr lang="en-US" sz="1400" dirty="0"/>
+            <a:endParaRPr lang="en-US" sz="2000" dirty="0"/>
           </a:p>
         </p:txBody>
       </p:sp>
@@ -9338,98 +9327,6 @@
               <a:t>Server sync status flag</a:t>
             </a:r>
             <a:endParaRPr lang="en-US" sz="1200" dirty="0"/>
-          </a:p>
-        </p:txBody>
-      </p:sp>
-      <p:sp>
-        <p:nvSpPr>
-          <p:cNvPr id="62" name="Shape 60">
-            <a:extLst>
-              <a:ext uri="{FF2B5EF4-FFF2-40B4-BE49-F238E27FC236}">
-                <a16:creationId xmlns:a16="http://schemas.microsoft.com/office/drawing/2014/main" id="{4965336E-60C6-0BC6-AB67-FDE4E52C1FAB}"/>
-              </a:ext>
-            </a:extLst>
-          </p:cNvPr>
-          <p:cNvSpPr/>
-          <p:nvPr/>
-        </p:nvSpPr>
-        <p:spPr>
-          <a:xfrm>
-            <a:off x="457200" y="4617720"/>
-            <a:ext cx="8229600" cy="320040"/>
-          </a:xfrm>
-          <a:prstGeom prst="rect">
-            <a:avLst/>
-          </a:prstGeom>
-          <a:solidFill>
-            <a:srgbClr val="E8F5E9"/>
-          </a:solidFill>
-          <a:ln w="7620">
-            <a:solidFill>
-              <a:srgbClr val="A5D6A7"/>
-            </a:solidFill>
-            <a:prstDash val="solid"/>
-          </a:ln>
-        </p:spPr>
-      </p:sp>
-      <p:sp>
-        <p:nvSpPr>
-          <p:cNvPr id="63" name="Text 61">
-            <a:extLst>
-              <a:ext uri="{FF2B5EF4-FFF2-40B4-BE49-F238E27FC236}">
-                <a16:creationId xmlns:a16="http://schemas.microsoft.com/office/drawing/2014/main" id="{148391AE-C106-383B-1BD0-A2F6E144AA86}"/>
-              </a:ext>
-            </a:extLst>
-          </p:cNvPr>
-          <p:cNvSpPr/>
-          <p:nvPr/>
-        </p:nvSpPr>
-        <p:spPr>
-          <a:xfrm>
-            <a:off x="548640" y="4727448"/>
-            <a:ext cx="8046720" cy="384048"/>
-          </a:xfrm>
-          <a:prstGeom prst="rect">
-            <a:avLst/>
-          </a:prstGeom>
-          <a:noFill/>
-          <a:ln/>
-        </p:spPr>
-        <p:txBody>
-          <a:bodyPr wrap="square" lIns="0" tIns="0" rIns="0" bIns="0" rtlCol="0" anchor="ctr"/>
-          <a:lstStyle/>
-          <a:p>
-            <a:pPr marL="0" indent="0">
-              <a:buNone/>
-            </a:pPr>
-            <a:r>
-              <a:rPr lang="en-US" sz="1400" b="1" dirty="0">
-                <a:solidFill>
-                  <a:srgbClr val="1B5E20"/>
-                </a:solidFill>
-                <a:latin typeface="Calibri" pitchFamily="34" charset="0"/>
-                <a:ea typeface="Calibri" pitchFamily="34" charset="-122"/>
-                <a:cs typeface="Calibri" pitchFamily="34" charset="-120"/>
-              </a:rPr>
-              <a:t>✔ All FRs traceable to survey  ✔ No contradictions found  ✔ Confirmed against ITU-T QoE standards  </a:t>
-            </a:r>
-          </a:p>
-          <a:p>
-            <a:pPr marL="0" indent="0">
-              <a:buNone/>
-            </a:pPr>
-            <a:r>
-              <a:rPr lang="en-US" sz="1400" b="1" dirty="0">
-                <a:solidFill>
-                  <a:srgbClr val="1B5E20"/>
-                </a:solidFill>
-                <a:latin typeface="Calibri" pitchFamily="34" charset="0"/>
-                <a:ea typeface="Calibri" pitchFamily="34" charset="-122"/>
-                <a:cs typeface="Calibri" pitchFamily="34" charset="-120"/>
-              </a:rPr>
-              <a:t>✔ 20 FRs + 20 NFRs fully documented</a:t>
-            </a:r>
-            <a:endParaRPr lang="en-US" sz="1400" dirty="0"/>
           </a:p>
         </p:txBody>
       </p:sp>
@@ -9739,7 +9636,9 @@
     <p:bg>
       <p:bgPr>
         <a:solidFill>
-          <a:srgbClr val="FFFFFF"/>
+          <a:schemeClr val="bg1">
+            <a:lumMod val="85000"/>
+          </a:schemeClr>
         </a:solidFill>
         <a:effectLst/>
       </p:bgPr>
@@ -10576,7 +10475,9 @@
     <p:bg>
       <p:bgPr>
         <a:solidFill>
-          <a:srgbClr val="0A2342"/>
+          <a:schemeClr val="bg1">
+            <a:lumMod val="85000"/>
+          </a:schemeClr>
         </a:solidFill>
         <a:effectLst/>
       </p:bgPr>
@@ -10677,9 +10578,6 @@
             </a:pPr>
             <a:r>
               <a:rPr lang="en-US" sz="1600" b="1" kern="0" spc="150" dirty="0">
-                <a:solidFill>
-                  <a:srgbClr val="00BCD4"/>
-                </a:solidFill>
                 <a:latin typeface="Calibri" pitchFamily="34" charset="0"/>
                 <a:ea typeface="Calibri" pitchFamily="34" charset="-122"/>
                 <a:cs typeface="Calibri" pitchFamily="34" charset="-120"/>
@@ -10829,7 +10727,7 @@
             <a:r>
               <a:rPr lang="en-US" sz="1600" b="1" dirty="0">
                 <a:solidFill>
-                  <a:srgbClr val="00BCD4"/>
+                  <a:schemeClr val="bg1"/>
                 </a:solidFill>
                 <a:latin typeface="Calibri" pitchFamily="34" charset="0"/>
                 <a:ea typeface="Calibri" pitchFamily="34" charset="-122"/>
@@ -10837,7 +10735,11 @@
               </a:rPr>
               <a:t>Requirements Gathered &amp; Validated</a:t>
             </a:r>
-            <a:endParaRPr lang="en-US" sz="1600" dirty="0"/>
+            <a:endParaRPr lang="en-US" sz="1600" dirty="0">
+              <a:solidFill>
+                <a:schemeClr val="bg1"/>
+              </a:solidFill>
+            </a:endParaRPr>
           </a:p>
         </p:txBody>
       </p:sp>
@@ -11025,7 +10927,7 @@
             <a:r>
               <a:rPr lang="en-US" sz="1600" b="1" dirty="0">
                 <a:solidFill>
-                  <a:srgbClr val="00BCD4"/>
+                  <a:schemeClr val="bg1"/>
                 </a:solidFill>
                 <a:latin typeface="Calibri" pitchFamily="34" charset="0"/>
                 <a:ea typeface="Calibri" pitchFamily="34" charset="-122"/>
@@ -11033,7 +10935,11 @@
               </a:rPr>
               <a:t>Requirements Fully Classified</a:t>
             </a:r>
-            <a:endParaRPr lang="en-US" sz="1600" dirty="0"/>
+            <a:endParaRPr lang="en-US" sz="1600" dirty="0">
+              <a:solidFill>
+                <a:schemeClr val="bg1"/>
+              </a:solidFill>
+            </a:endParaRPr>
           </a:p>
         </p:txBody>
       </p:sp>
@@ -11113,17 +11019,14 @@
               <a:buNone/>
             </a:pPr>
             <a:r>
-              <a:rPr lang="en-US" sz="1200" b="1" kern="0" spc="150" dirty="0">
-                <a:solidFill>
-                  <a:srgbClr val="00BCD4"/>
-                </a:solidFill>
+              <a:rPr lang="en-US" sz="3200" b="1" kern="0" spc="150" dirty="0">
                 <a:latin typeface="Calibri" pitchFamily="34" charset="0"/>
                 <a:ea typeface="Calibri" pitchFamily="34" charset="-122"/>
                 <a:cs typeface="Calibri" pitchFamily="34" charset="-120"/>
               </a:rPr>
               <a:t>WHAT'S NEXT</a:t>
             </a:r>
-            <a:endParaRPr lang="en-US" sz="1200" dirty="0"/>
+            <a:endParaRPr lang="en-US" sz="3200" dirty="0"/>
           </a:p>
         </p:txBody>
       </p:sp>
@@ -11224,7 +11127,7 @@
             <a:r>
               <a:rPr lang="en-US" sz="1100" b="1" dirty="0">
                 <a:solidFill>
-                  <a:srgbClr val="00BCD4"/>
+                  <a:schemeClr val="bg1"/>
                 </a:solidFill>
                 <a:latin typeface="Calibri" pitchFamily="34" charset="0"/>
                 <a:ea typeface="Calibri" pitchFamily="34" charset="-122"/>
@@ -11232,7 +11135,11 @@
               </a:rPr>
               <a:t>Task 4</a:t>
             </a:r>
-            <a:endParaRPr lang="en-US" sz="1100" dirty="0"/>
+            <a:endParaRPr lang="en-US" sz="1100" dirty="0">
+              <a:solidFill>
+                <a:schemeClr val="bg1"/>
+              </a:solidFill>
+            </a:endParaRPr>
           </a:p>
         </p:txBody>
       </p:sp>
@@ -11269,7 +11176,7 @@
             <a:r>
               <a:rPr lang="en-US" sz="1600" b="1" dirty="0">
                 <a:solidFill>
-                  <a:srgbClr val="00BCD4"/>
+                  <a:schemeClr val="bg1"/>
                 </a:solidFill>
                 <a:latin typeface="Calibri" pitchFamily="34" charset="0"/>
                 <a:ea typeface="Calibri" pitchFamily="34" charset="-122"/>
@@ -11277,7 +11184,11 @@
               </a:rPr>
               <a:t>System Modeling and Design</a:t>
             </a:r>
-            <a:endParaRPr lang="en-US" sz="1600" dirty="0"/>
+            <a:endParaRPr lang="en-US" sz="1600" dirty="0">
+              <a:solidFill>
+                <a:schemeClr val="bg1"/>
+              </a:solidFill>
+            </a:endParaRPr>
           </a:p>
         </p:txBody>
       </p:sp>
@@ -11320,7 +11231,7 @@
                 <a:ea typeface="Calibri" pitchFamily="34" charset="-122"/>
                 <a:cs typeface="Calibri" pitchFamily="34" charset="-120"/>
               </a:rPr>
-              <a:t>Translate the SRS into architecture diagrams, database schema, UI wireframes, and API contracts.</a:t>
+              <a:t>Translating the SRS into architecture diagrams, database schema, UI wireframes, and API contracts.</a:t>
             </a:r>
             <a:endParaRPr lang="en-US" sz="1100" dirty="0"/>
           </a:p>
@@ -11389,9 +11300,6 @@
             </a:pPr>
             <a:r>
               <a:rPr lang="en-US" sz="3600" b="1" dirty="0">
-                <a:solidFill>
-                  <a:srgbClr val="FFFFFF"/>
-                </a:solidFill>
                 <a:latin typeface="Calibri" pitchFamily="34" charset="0"/>
                 <a:ea typeface="Calibri" pitchFamily="34" charset="-122"/>
                 <a:cs typeface="Calibri" pitchFamily="34" charset="-120"/>
@@ -11541,7 +11449,7 @@
             <a:r>
               <a:rPr lang="en-US" sz="1600" b="1" dirty="0">
                 <a:solidFill>
-                  <a:srgbClr val="00BCD4"/>
+                  <a:schemeClr val="bg1"/>
                 </a:solidFill>
                 <a:latin typeface="Calibri" pitchFamily="34" charset="0"/>
                 <a:ea typeface="Calibri" pitchFamily="34" charset="-122"/>
@@ -11549,7 +11457,11 @@
               </a:rPr>
               <a:t>Conflicts &amp; Gaps Resolved</a:t>
             </a:r>
-            <a:endParaRPr lang="en-US" sz="1600" dirty="0"/>
+            <a:endParaRPr lang="en-US" sz="1600" dirty="0">
+              <a:solidFill>
+                <a:schemeClr val="bg1"/>
+              </a:solidFill>
+            </a:endParaRPr>
           </a:p>
         </p:txBody>
       </p:sp>
@@ -11737,7 +11649,7 @@
             <a:r>
               <a:rPr lang="en-US" sz="1600" b="1" dirty="0">
                 <a:solidFill>
-                  <a:srgbClr val="00BCD4"/>
+                  <a:schemeClr val="bg1"/>
                 </a:solidFill>
                 <a:latin typeface="Calibri" pitchFamily="34" charset="0"/>
                 <a:ea typeface="Calibri" pitchFamily="34" charset="-122"/>
@@ -11745,7 +11657,11 @@
               </a:rPr>
               <a:t>Priorities Established</a:t>
             </a:r>
-            <a:endParaRPr lang="en-US" sz="1600" dirty="0"/>
+            <a:endParaRPr lang="en-US" sz="1600" dirty="0">
+              <a:solidFill>
+                <a:schemeClr val="bg1"/>
+              </a:solidFill>
+            </a:endParaRPr>
           </a:p>
         </p:txBody>
       </p:sp>
@@ -11849,6 +11765,16 @@
 <file path=ppt/slides/slide2.xml><?xml version="1.0" encoding="utf-8"?>
 <p:sld xmlns:a="http://schemas.openxmlformats.org/drawingml/2006/main" xmlns:r="http://schemas.openxmlformats.org/officeDocument/2006/relationships" xmlns:p="http://schemas.openxmlformats.org/presentationml/2006/main">
   <p:cSld>
+    <p:bg>
+      <p:bgPr>
+        <a:solidFill>
+          <a:schemeClr val="bg1">
+            <a:lumMod val="85000"/>
+          </a:schemeClr>
+        </a:solidFill>
+        <a:effectLst/>
+      </p:bgPr>
+    </p:bg>
     <p:spTree>
       <p:nvGrpSpPr>
         <p:cNvPr id="1" name=""/>
@@ -11953,7 +11879,7 @@
         </p:nvSpPr>
         <p:spPr>
           <a:xfrm>
-            <a:off x="411480" y="897636"/>
+            <a:off x="2491740" y="2137404"/>
             <a:ext cx="4160520" cy="292608"/>
           </a:xfrm>
           <a:prstGeom prst="rect">
@@ -11984,7 +11910,7 @@
         </p:nvSpPr>
         <p:spPr>
           <a:xfrm>
-            <a:off x="502920" y="897636"/>
+            <a:off x="2583180" y="2137404"/>
             <a:ext cx="3977640" cy="292608"/>
           </a:xfrm>
           <a:prstGeom prst="rect">
@@ -11997,11 +11923,11 @@
           <a:bodyPr wrap="square" lIns="0" tIns="0" rIns="0" bIns="0" rtlCol="0" anchor="ctr"/>
           <a:lstStyle/>
           <a:p>
-            <a:pPr marL="0" indent="0">
-              <a:buNone/>
-            </a:pPr>
-            <a:r>
-              <a:rPr lang="en-US" sz="1200" b="1" kern="0" spc="100" dirty="0">
+            <a:pPr marL="0" indent="0" algn="ctr">
+              <a:buNone/>
+            </a:pPr>
+            <a:r>
+              <a:rPr lang="en-US" b="1" kern="0" spc="100" dirty="0">
                 <a:solidFill>
                   <a:srgbClr val="FFFFFF"/>
                 </a:solidFill>
@@ -12009,9 +11935,9 @@
                 <a:ea typeface="Calibri" pitchFamily="34" charset="-122"/>
                 <a:cs typeface="Calibri" pitchFamily="34" charset="-120"/>
               </a:rPr>
-              <a:t>What We Covered In This Phase</a:t>
-            </a:r>
-            <a:endParaRPr lang="en-US" sz="1200" dirty="0"/>
+              <a:t>What We Covered</a:t>
+            </a:r>
+            <a:endParaRPr lang="en-US" dirty="0"/>
           </a:p>
         </p:txBody>
       </p:sp>
@@ -12029,7 +11955,7 @@
         </p:nvSpPr>
         <p:spPr>
           <a:xfrm>
-            <a:off x="411480" y="1281684"/>
+            <a:off x="320040" y="2632873"/>
             <a:ext cx="4160520" cy="576072"/>
           </a:xfrm>
           <a:prstGeom prst="rect">
@@ -12060,7 +11986,7 @@
         </p:nvSpPr>
         <p:spPr>
           <a:xfrm>
-            <a:off x="466344" y="1391412"/>
+            <a:off x="374904" y="2742601"/>
             <a:ext cx="384048" cy="384048"/>
           </a:xfrm>
           <a:prstGeom prst="ellipse">
@@ -12091,7 +12017,7 @@
         </p:nvSpPr>
         <p:spPr>
           <a:xfrm>
-            <a:off x="466344" y="1391412"/>
+            <a:off x="374904" y="2742601"/>
             <a:ext cx="384048" cy="384048"/>
           </a:xfrm>
           <a:prstGeom prst="rect">
@@ -12133,7 +12059,7 @@
         </p:nvSpPr>
         <p:spPr>
           <a:xfrm>
-            <a:off x="960120" y="1327404"/>
+            <a:off x="868680" y="2812868"/>
             <a:ext cx="3474720" cy="246888"/>
           </a:xfrm>
           <a:prstGeom prst="rect">
@@ -12161,48 +12087,6 @@
               <a:t>Review &amp; Analyse Requirements</a:t>
             </a:r>
             <a:endParaRPr lang="en-US" sz="1600" dirty="0"/>
-          </a:p>
-        </p:txBody>
-      </p:sp>
-      <p:sp>
-        <p:nvSpPr>
-          <p:cNvPr id="10" name="Text 9">
-            <a:extLst>
-              <a:ext uri="{FF2B5EF4-FFF2-40B4-BE49-F238E27FC236}">
-                <a16:creationId xmlns:a16="http://schemas.microsoft.com/office/drawing/2014/main" id="{8D88C4E3-49D7-D825-56DF-57CC01A18A2C}"/>
-              </a:ext>
-            </a:extLst>
-          </p:cNvPr>
-          <p:cNvSpPr/>
-          <p:nvPr/>
-        </p:nvSpPr>
-        <p:spPr>
-          <a:xfrm>
-            <a:off x="960120" y="1583436"/>
-            <a:ext cx="3474720" cy="237744"/>
-          </a:xfrm>
-          <a:prstGeom prst="rect">
-            <a:avLst/>
-          </a:prstGeom>
-          <a:noFill/>
-          <a:ln/>
-        </p:spPr>
-        <p:txBody>
-          <a:bodyPr wrap="square" lIns="0" tIns="0" rIns="0" bIns="0" rtlCol="0" anchor="ctr"/>
-          <a:lstStyle/>
-          <a:p>
-            <a:pPr marL="0" indent="0">
-              <a:buNone/>
-            </a:pPr>
-            <a:r>
-              <a:rPr lang="en-US" sz="1100" dirty="0">
-                <a:latin typeface="Calibri" pitchFamily="34" charset="0"/>
-                <a:ea typeface="Calibri" pitchFamily="34" charset="-122"/>
-                <a:cs typeface="Calibri" pitchFamily="34" charset="-120"/>
-              </a:rPr>
-              <a:t>Survey of 190 respondents — completeness, clarity, feasibility, dependencies, inconsistencies &amp; ambiguities.</a:t>
-            </a:r>
-            <a:endParaRPr lang="en-US" sz="1100" dirty="0"/>
           </a:p>
         </p:txBody>
       </p:sp>
@@ -12220,7 +12104,7 @@
         </p:nvSpPr>
         <p:spPr>
           <a:xfrm>
-            <a:off x="411480" y="1940052"/>
+            <a:off x="4882896" y="2632873"/>
             <a:ext cx="4160520" cy="576072"/>
           </a:xfrm>
           <a:prstGeom prst="rect">
@@ -12251,7 +12135,7 @@
         </p:nvSpPr>
         <p:spPr>
           <a:xfrm>
-            <a:off x="466344" y="2049780"/>
+            <a:off x="4937760" y="2742601"/>
             <a:ext cx="384048" cy="384048"/>
           </a:xfrm>
           <a:prstGeom prst="ellipse">
@@ -12282,7 +12166,7 @@
         </p:nvSpPr>
         <p:spPr>
           <a:xfrm>
-            <a:off x="466344" y="2049780"/>
+            <a:off x="4937760" y="2742601"/>
             <a:ext cx="384048" cy="384048"/>
           </a:xfrm>
           <a:prstGeom prst="rect">
@@ -12324,7 +12208,7 @@
         </p:nvSpPr>
         <p:spPr>
           <a:xfrm>
-            <a:off x="960120" y="1985772"/>
+            <a:off x="5445252" y="2797465"/>
             <a:ext cx="3474720" cy="246888"/>
           </a:xfrm>
           <a:prstGeom prst="rect">
@@ -12352,48 +12236,6 @@
               <a:t>Prioritize Requirements</a:t>
             </a:r>
             <a:endParaRPr lang="en-US" sz="1600" dirty="0"/>
-          </a:p>
-        </p:txBody>
-      </p:sp>
-      <p:sp>
-        <p:nvSpPr>
-          <p:cNvPr id="15" name="Text 14">
-            <a:extLst>
-              <a:ext uri="{FF2B5EF4-FFF2-40B4-BE49-F238E27FC236}">
-                <a16:creationId xmlns:a16="http://schemas.microsoft.com/office/drawing/2014/main" id="{1C2A5494-94D9-0356-FF5C-3663969C210D}"/>
-              </a:ext>
-            </a:extLst>
-          </p:cNvPr>
-          <p:cNvSpPr/>
-          <p:nvPr/>
-        </p:nvSpPr>
-        <p:spPr>
-          <a:xfrm>
-            <a:off x="960120" y="2241804"/>
-            <a:ext cx="3474720" cy="237744"/>
-          </a:xfrm>
-          <a:prstGeom prst="rect">
-            <a:avLst/>
-          </a:prstGeom>
-          <a:noFill/>
-          <a:ln/>
-        </p:spPr>
-        <p:txBody>
-          <a:bodyPr wrap="square" lIns="0" tIns="0" rIns="0" bIns="0" rtlCol="0" anchor="ctr"/>
-          <a:lstStyle/>
-          <a:p>
-            <a:pPr marL="0" indent="0">
-              <a:buNone/>
-            </a:pPr>
-            <a:r>
-              <a:rPr lang="en-US" sz="1100" dirty="0">
-                <a:latin typeface="Calibri" pitchFamily="34" charset="0"/>
-                <a:ea typeface="Calibri" pitchFamily="34" charset="-122"/>
-                <a:cs typeface="Calibri" pitchFamily="34" charset="-120"/>
-              </a:rPr>
-              <a:t>Importance × Feasibility matrix and MoSCoW classification (Must-Have → Won't-Have).</a:t>
-            </a:r>
-            <a:endParaRPr lang="en-US" sz="1100" dirty="0"/>
           </a:p>
         </p:txBody>
       </p:sp>
@@ -12411,7 +12253,7 @@
         </p:nvSpPr>
         <p:spPr>
           <a:xfrm>
-            <a:off x="411480" y="2598420"/>
+            <a:off x="320040" y="3558110"/>
             <a:ext cx="4160520" cy="576072"/>
           </a:xfrm>
           <a:prstGeom prst="rect">
@@ -12442,7 +12284,7 @@
         </p:nvSpPr>
         <p:spPr>
           <a:xfrm>
-            <a:off x="466344" y="2708148"/>
+            <a:off x="374904" y="3667838"/>
             <a:ext cx="384048" cy="384048"/>
           </a:xfrm>
           <a:prstGeom prst="ellipse">
@@ -12473,7 +12315,7 @@
         </p:nvSpPr>
         <p:spPr>
           <a:xfrm>
-            <a:off x="466344" y="2708148"/>
+            <a:off x="374904" y="3667838"/>
             <a:ext cx="384048" cy="384048"/>
           </a:xfrm>
           <a:prstGeom prst="rect">
@@ -12515,7 +12357,7 @@
         </p:nvSpPr>
         <p:spPr>
           <a:xfrm>
-            <a:off x="960120" y="2644140"/>
+            <a:off x="845820" y="3696402"/>
             <a:ext cx="3474720" cy="246888"/>
           </a:xfrm>
           <a:prstGeom prst="rect">
@@ -12543,48 +12385,6 @@
               <a:t>Classify Requirements</a:t>
             </a:r>
             <a:endParaRPr lang="en-US" sz="1600" dirty="0"/>
-          </a:p>
-        </p:txBody>
-      </p:sp>
-      <p:sp>
-        <p:nvSpPr>
-          <p:cNvPr id="20" name="Text 19">
-            <a:extLst>
-              <a:ext uri="{FF2B5EF4-FFF2-40B4-BE49-F238E27FC236}">
-                <a16:creationId xmlns:a16="http://schemas.microsoft.com/office/drawing/2014/main" id="{F340C310-8DCA-6E03-2E3F-27DDFDD1B84B}"/>
-              </a:ext>
-            </a:extLst>
-          </p:cNvPr>
-          <p:cNvSpPr/>
-          <p:nvPr/>
-        </p:nvSpPr>
-        <p:spPr>
-          <a:xfrm>
-            <a:off x="960120" y="2900172"/>
-            <a:ext cx="3474720" cy="237744"/>
-          </a:xfrm>
-          <a:prstGeom prst="rect">
-            <a:avLst/>
-          </a:prstGeom>
-          <a:noFill/>
-          <a:ln/>
-        </p:spPr>
-        <p:txBody>
-          <a:bodyPr wrap="square" lIns="0" tIns="0" rIns="0" bIns="0" rtlCol="0" anchor="ctr"/>
-          <a:lstStyle/>
-          <a:p>
-            <a:pPr marL="0" indent="0">
-              <a:buNone/>
-            </a:pPr>
-            <a:r>
-              <a:rPr lang="en-US" sz="1100" dirty="0">
-                <a:latin typeface="Calibri" pitchFamily="34" charset="0"/>
-                <a:ea typeface="Calibri" pitchFamily="34" charset="-122"/>
-                <a:cs typeface="Calibri" pitchFamily="34" charset="-120"/>
-              </a:rPr>
-              <a:t>10 Functional Requirements (FR1–FR10) and 20 Non-Functional Requirements across 6 quality dimensions.</a:t>
-            </a:r>
-            <a:endParaRPr lang="en-US" sz="1100" dirty="0"/>
           </a:p>
         </p:txBody>
       </p:sp>
@@ -12602,7 +12402,7 @@
         </p:nvSpPr>
         <p:spPr>
           <a:xfrm>
-            <a:off x="411480" y="3256788"/>
+            <a:off x="4882896" y="3558110"/>
             <a:ext cx="4160520" cy="576072"/>
           </a:xfrm>
           <a:prstGeom prst="rect">
@@ -12633,7 +12433,7 @@
         </p:nvSpPr>
         <p:spPr>
           <a:xfrm>
-            <a:off x="466344" y="3366516"/>
+            <a:off x="4937760" y="3667838"/>
             <a:ext cx="384048" cy="384048"/>
           </a:xfrm>
           <a:prstGeom prst="ellipse">
@@ -12664,7 +12464,7 @@
         </p:nvSpPr>
         <p:spPr>
           <a:xfrm>
-            <a:off x="466344" y="3366516"/>
+            <a:off x="4937760" y="3667838"/>
             <a:ext cx="384048" cy="384048"/>
           </a:xfrm>
           <a:prstGeom prst="rect">
@@ -12686,7 +12486,7 @@
                   <a:srgbClr val="FFFFFF"/>
                 </a:solidFill>
               </a:rPr>
-              <a:t>SRS</a:t>
+              <a:t>IV</a:t>
             </a:r>
             <a:endParaRPr lang="en-US" sz="1100" dirty="0"/>
           </a:p>
@@ -12706,7 +12506,7 @@
         </p:nvSpPr>
         <p:spPr>
           <a:xfrm>
-            <a:off x="960120" y="3302508"/>
+            <a:off x="5445252" y="3727274"/>
             <a:ext cx="3474720" cy="246888"/>
           </a:xfrm>
           <a:prstGeom prst="rect">
@@ -12731,51 +12531,20 @@
                 <a:ea typeface="Calibri" pitchFamily="34" charset="-122"/>
                 <a:cs typeface="Calibri" pitchFamily="34" charset="-120"/>
               </a:rPr>
-              <a:t>Software Requirements Spec.</a:t>
+              <a:t>Software Requirements </a:t>
+            </a:r>
+            <a:r>
+              <a:rPr lang="en-US" sz="1600" b="1" dirty="0" err="1">
+                <a:solidFill>
+                  <a:srgbClr val="0A2342"/>
+                </a:solidFill>
+                <a:latin typeface="Calibri" pitchFamily="34" charset="0"/>
+                <a:ea typeface="Calibri" pitchFamily="34" charset="-122"/>
+                <a:cs typeface="Calibri" pitchFamily="34" charset="-120"/>
+              </a:rPr>
+              <a:t>Specificaton</a:t>
             </a:r>
             <a:endParaRPr lang="en-US" sz="1600" dirty="0"/>
-          </a:p>
-        </p:txBody>
-      </p:sp>
-      <p:sp>
-        <p:nvSpPr>
-          <p:cNvPr id="25" name="Text 24">
-            <a:extLst>
-              <a:ext uri="{FF2B5EF4-FFF2-40B4-BE49-F238E27FC236}">
-                <a16:creationId xmlns:a16="http://schemas.microsoft.com/office/drawing/2014/main" id="{EC51CD73-16CF-F8A8-5430-481F727E5364}"/>
-              </a:ext>
-            </a:extLst>
-          </p:cNvPr>
-          <p:cNvSpPr/>
-          <p:nvPr/>
-        </p:nvSpPr>
-        <p:spPr>
-          <a:xfrm>
-            <a:off x="960120" y="3558540"/>
-            <a:ext cx="3474720" cy="237744"/>
-          </a:xfrm>
-          <a:prstGeom prst="rect">
-            <a:avLst/>
-          </a:prstGeom>
-          <a:noFill/>
-          <a:ln/>
-        </p:spPr>
-        <p:txBody>
-          <a:bodyPr wrap="square" lIns="0" tIns="0" rIns="0" bIns="0" rtlCol="0" anchor="ctr"/>
-          <a:lstStyle/>
-          <a:p>
-            <a:pPr marL="0" indent="0">
-              <a:buNone/>
-            </a:pPr>
-            <a:r>
-              <a:rPr lang="en-US" sz="1100" dirty="0">
-                <a:latin typeface="Calibri" pitchFamily="34" charset="0"/>
-                <a:ea typeface="Calibri" pitchFamily="34" charset="-122"/>
-                <a:cs typeface="Calibri" pitchFamily="34" charset="-120"/>
-              </a:rPr>
-              <a:t>Full SRS document v1.0 — use cases, data dictionary, system constraints, and assumptions.</a:t>
-            </a:r>
-            <a:endParaRPr lang="en-US" sz="1100" dirty="0"/>
           </a:p>
         </p:txBody>
       </p:sp>
@@ -12793,7 +12562,7 @@
         </p:nvSpPr>
         <p:spPr>
           <a:xfrm>
-            <a:off x="411480" y="3915156"/>
+            <a:off x="2434590" y="4306872"/>
             <a:ext cx="4160520" cy="576072"/>
           </a:xfrm>
           <a:prstGeom prst="rect">
@@ -12824,7 +12593,7 @@
         </p:nvSpPr>
         <p:spPr>
           <a:xfrm>
-            <a:off x="466344" y="4024884"/>
+            <a:off x="2489454" y="4402884"/>
             <a:ext cx="384048" cy="384048"/>
           </a:xfrm>
           <a:prstGeom prst="ellipse">
@@ -12855,7 +12624,7 @@
         </p:nvSpPr>
         <p:spPr>
           <a:xfrm>
-            <a:off x="466344" y="4024884"/>
+            <a:off x="2489454" y="4402884"/>
             <a:ext cx="384048" cy="384048"/>
           </a:xfrm>
           <a:prstGeom prst="rect">
@@ -12877,7 +12646,7 @@
                   <a:srgbClr val="FFFFFF"/>
                 </a:solidFill>
               </a:rPr>
-              <a:t>IV</a:t>
+              <a:t>V</a:t>
             </a:r>
             <a:endParaRPr lang="en-US" sz="1100" dirty="0"/>
           </a:p>
@@ -12897,7 +12666,7 @@
         </p:nvSpPr>
         <p:spPr>
           <a:xfrm>
-            <a:off x="960120" y="3960876"/>
+            <a:off x="2983230" y="4444733"/>
             <a:ext cx="3474720" cy="246888"/>
           </a:xfrm>
           <a:prstGeom prst="rect">
@@ -12925,928 +12694,6 @@
               <a:t>Validate with Stakeholders</a:t>
             </a:r>
             <a:endParaRPr lang="en-US" sz="1600" dirty="0"/>
-          </a:p>
-        </p:txBody>
-      </p:sp>
-      <p:sp>
-        <p:nvSpPr>
-          <p:cNvPr id="30" name="Text 29">
-            <a:extLst>
-              <a:ext uri="{FF2B5EF4-FFF2-40B4-BE49-F238E27FC236}">
-                <a16:creationId xmlns:a16="http://schemas.microsoft.com/office/drawing/2014/main" id="{D8FDEA1A-A527-0EA3-74D9-ECD5749DBE73}"/>
-              </a:ext>
-            </a:extLst>
-          </p:cNvPr>
-          <p:cNvSpPr/>
-          <p:nvPr/>
-        </p:nvSpPr>
-        <p:spPr>
-          <a:xfrm>
-            <a:off x="960120" y="4216908"/>
-            <a:ext cx="3474720" cy="237744"/>
-          </a:xfrm>
-          <a:prstGeom prst="rect">
-            <a:avLst/>
-          </a:prstGeom>
-          <a:noFill/>
-          <a:ln/>
-        </p:spPr>
-        <p:txBody>
-          <a:bodyPr wrap="square" lIns="0" tIns="0" rIns="0" bIns="0" rtlCol="0" anchor="ctr"/>
-          <a:lstStyle/>
-          <a:p>
-            <a:pPr marL="0" indent="0">
-              <a:buNone/>
-            </a:pPr>
-            <a:r>
-              <a:rPr lang="en-US" sz="1100" dirty="0">
-                <a:latin typeface="Calibri" pitchFamily="34" charset="0"/>
-                <a:ea typeface="Calibri" pitchFamily="34" charset="-122"/>
-                <a:cs typeface="Calibri" pitchFamily="34" charset="-120"/>
-              </a:rPr>
-              <a:t>Requirements traced back to survey data, cross-checked for contradictions, and aligned with ITU-T QoE standards.</a:t>
-            </a:r>
-            <a:endParaRPr lang="en-US" sz="1100" dirty="0"/>
-          </a:p>
-        </p:txBody>
-      </p:sp>
-      <p:sp>
-        <p:nvSpPr>
-          <p:cNvPr id="31" name="Shape 30">
-            <a:extLst>
-              <a:ext uri="{FF2B5EF4-FFF2-40B4-BE49-F238E27FC236}">
-                <a16:creationId xmlns:a16="http://schemas.microsoft.com/office/drawing/2014/main" id="{FF498B6B-D6B0-3486-9633-EAA1191F04D7}"/>
-              </a:ext>
-            </a:extLst>
-          </p:cNvPr>
-          <p:cNvSpPr/>
-          <p:nvPr/>
-        </p:nvSpPr>
-        <p:spPr>
-          <a:xfrm>
-            <a:off x="4846320" y="897636"/>
-            <a:ext cx="3840480" cy="292608"/>
-          </a:xfrm>
-          <a:prstGeom prst="rect">
-            <a:avLst/>
-          </a:prstGeom>
-          <a:solidFill>
-            <a:srgbClr val="0097A7"/>
-          </a:solidFill>
-          <a:ln w="12700">
-            <a:solidFill>
-              <a:srgbClr val="0097A7"/>
-            </a:solidFill>
-            <a:prstDash val="solid"/>
-          </a:ln>
-        </p:spPr>
-      </p:sp>
-      <p:sp>
-        <p:nvSpPr>
-          <p:cNvPr id="32" name="Text 31">
-            <a:extLst>
-              <a:ext uri="{FF2B5EF4-FFF2-40B4-BE49-F238E27FC236}">
-                <a16:creationId xmlns:a16="http://schemas.microsoft.com/office/drawing/2014/main" id="{2A182B14-1E7E-AF6D-14F0-153D57DEDDB1}"/>
-              </a:ext>
-            </a:extLst>
-          </p:cNvPr>
-          <p:cNvSpPr/>
-          <p:nvPr/>
-        </p:nvSpPr>
-        <p:spPr>
-          <a:xfrm>
-            <a:off x="4937760" y="897636"/>
-            <a:ext cx="3657600" cy="292608"/>
-          </a:xfrm>
-          <a:prstGeom prst="rect">
-            <a:avLst/>
-          </a:prstGeom>
-          <a:noFill/>
-          <a:ln/>
-        </p:spPr>
-        <p:txBody>
-          <a:bodyPr wrap="square" lIns="0" tIns="0" rIns="0" bIns="0" rtlCol="0" anchor="ctr"/>
-          <a:lstStyle/>
-          <a:p>
-            <a:pPr marL="0" indent="0">
-              <a:buNone/>
-            </a:pPr>
-            <a:r>
-              <a:rPr lang="en-US" sz="1200" b="1" kern="0" spc="100" dirty="0">
-                <a:solidFill>
-                  <a:srgbClr val="FFFFFF"/>
-                </a:solidFill>
-                <a:latin typeface="Calibri" pitchFamily="34" charset="0"/>
-                <a:ea typeface="Calibri" pitchFamily="34" charset="-122"/>
-                <a:cs typeface="Calibri" pitchFamily="34" charset="-120"/>
-              </a:rPr>
-              <a:t>PROJECT CONTEXT</a:t>
-            </a:r>
-            <a:endParaRPr lang="en-US" sz="1200" dirty="0"/>
-          </a:p>
-        </p:txBody>
-      </p:sp>
-      <p:sp>
-        <p:nvSpPr>
-          <p:cNvPr id="33" name="Shape 32">
-            <a:extLst>
-              <a:ext uri="{FF2B5EF4-FFF2-40B4-BE49-F238E27FC236}">
-                <a16:creationId xmlns:a16="http://schemas.microsoft.com/office/drawing/2014/main" id="{2AC6BFCF-B8C3-A7AE-309B-FDEDD18DFBD9}"/>
-              </a:ext>
-            </a:extLst>
-          </p:cNvPr>
-          <p:cNvSpPr/>
-          <p:nvPr/>
-        </p:nvSpPr>
-        <p:spPr>
-          <a:xfrm>
-            <a:off x="4846320" y="1299972"/>
-            <a:ext cx="3840480" cy="713232"/>
-          </a:xfrm>
-          <a:prstGeom prst="rect">
-            <a:avLst/>
-          </a:prstGeom>
-          <a:solidFill>
-            <a:srgbClr val="FAFEFF"/>
-          </a:solidFill>
-          <a:ln w="6350">
-            <a:solidFill>
-              <a:srgbClr val="BBDEFB"/>
-            </a:solidFill>
-            <a:prstDash val="solid"/>
-          </a:ln>
-          <a:effectLst>
-            <a:outerShdw blurRad="50800" dist="25400" dir="8100000" algn="bl" rotWithShape="0">
-              <a:srgbClr val="000000">
-                <a:alpha val="6000"/>
-              </a:srgbClr>
-            </a:outerShdw>
-          </a:effectLst>
-        </p:spPr>
-      </p:sp>
-      <p:sp>
-        <p:nvSpPr>
-          <p:cNvPr id="34" name="Shape 33">
-            <a:extLst>
-              <a:ext uri="{FF2B5EF4-FFF2-40B4-BE49-F238E27FC236}">
-                <a16:creationId xmlns:a16="http://schemas.microsoft.com/office/drawing/2014/main" id="{0B775C35-0452-F9F3-6814-5FA9350B71E3}"/>
-              </a:ext>
-            </a:extLst>
-          </p:cNvPr>
-          <p:cNvSpPr/>
-          <p:nvPr/>
-        </p:nvSpPr>
-        <p:spPr>
-          <a:xfrm>
-            <a:off x="4846320" y="1299972"/>
-            <a:ext cx="64008" cy="713232"/>
-          </a:xfrm>
-          <a:prstGeom prst="rect">
-            <a:avLst/>
-          </a:prstGeom>
-          <a:solidFill>
-            <a:srgbClr val="0097A7"/>
-          </a:solidFill>
-          <a:ln w="12700">
-            <a:solidFill>
-              <a:srgbClr val="0097A7"/>
-            </a:solidFill>
-            <a:prstDash val="solid"/>
-          </a:ln>
-        </p:spPr>
-      </p:sp>
-      <p:sp>
-        <p:nvSpPr>
-          <p:cNvPr id="35" name="Text 34">
-            <a:extLst>
-              <a:ext uri="{FF2B5EF4-FFF2-40B4-BE49-F238E27FC236}">
-                <a16:creationId xmlns:a16="http://schemas.microsoft.com/office/drawing/2014/main" id="{19304834-8ADE-D455-5462-07AC3D4D64A7}"/>
-              </a:ext>
-            </a:extLst>
-          </p:cNvPr>
-          <p:cNvSpPr/>
-          <p:nvPr/>
-        </p:nvSpPr>
-        <p:spPr>
-          <a:xfrm>
-            <a:off x="5001768" y="1373124"/>
-            <a:ext cx="1280160" cy="365760"/>
-          </a:xfrm>
-          <a:prstGeom prst="rect">
-            <a:avLst/>
-          </a:prstGeom>
-          <a:noFill/>
-          <a:ln/>
-        </p:spPr>
-        <p:txBody>
-          <a:bodyPr wrap="square" lIns="0" tIns="0" rIns="0" bIns="0" rtlCol="0" anchor="ctr"/>
-          <a:lstStyle/>
-          <a:p>
-            <a:pPr marL="0" indent="0">
-              <a:buNone/>
-            </a:pPr>
-            <a:r>
-              <a:rPr lang="en-US" sz="3600" b="1" dirty="0">
-                <a:solidFill>
-                  <a:srgbClr val="0097A7"/>
-                </a:solidFill>
-                <a:latin typeface="Calibri" pitchFamily="34" charset="0"/>
-                <a:ea typeface="Calibri" pitchFamily="34" charset="-122"/>
-                <a:cs typeface="Calibri" pitchFamily="34" charset="-120"/>
-              </a:rPr>
-              <a:t>190</a:t>
-            </a:r>
-            <a:endParaRPr lang="en-US" sz="3600" dirty="0"/>
-          </a:p>
-        </p:txBody>
-      </p:sp>
-      <p:sp>
-        <p:nvSpPr>
-          <p:cNvPr id="36" name="Text 35">
-            <a:extLst>
-              <a:ext uri="{FF2B5EF4-FFF2-40B4-BE49-F238E27FC236}">
-                <a16:creationId xmlns:a16="http://schemas.microsoft.com/office/drawing/2014/main" id="{47C53A90-88A5-564C-778D-1BB99D82A171}"/>
-              </a:ext>
-            </a:extLst>
-          </p:cNvPr>
-          <p:cNvSpPr/>
-          <p:nvPr/>
-        </p:nvSpPr>
-        <p:spPr>
-          <a:xfrm>
-            <a:off x="6336792" y="1391412"/>
-            <a:ext cx="2240280" cy="256032"/>
-          </a:xfrm>
-          <a:prstGeom prst="rect">
-            <a:avLst/>
-          </a:prstGeom>
-          <a:noFill/>
-          <a:ln/>
-        </p:spPr>
-        <p:txBody>
-          <a:bodyPr wrap="square" lIns="0" tIns="0" rIns="0" bIns="0" rtlCol="0" anchor="ctr"/>
-          <a:lstStyle/>
-          <a:p>
-            <a:pPr marL="0" indent="0">
-              <a:buNone/>
-            </a:pPr>
-            <a:r>
-              <a:rPr lang="en-US" sz="1600" b="1" dirty="0">
-                <a:solidFill>
-                  <a:srgbClr val="0A2342"/>
-                </a:solidFill>
-                <a:latin typeface="Calibri" pitchFamily="34" charset="0"/>
-                <a:ea typeface="Calibri" pitchFamily="34" charset="-122"/>
-                <a:cs typeface="Calibri" pitchFamily="34" charset="-120"/>
-              </a:rPr>
-              <a:t>Survey Respondents</a:t>
-            </a:r>
-            <a:endParaRPr lang="en-US" sz="1600" dirty="0"/>
-          </a:p>
-        </p:txBody>
-      </p:sp>
-      <p:sp>
-        <p:nvSpPr>
-          <p:cNvPr id="37" name="Text 36">
-            <a:extLst>
-              <a:ext uri="{FF2B5EF4-FFF2-40B4-BE49-F238E27FC236}">
-                <a16:creationId xmlns:a16="http://schemas.microsoft.com/office/drawing/2014/main" id="{DA48CC66-2C24-0802-10E1-829F270ADE06}"/>
-              </a:ext>
-            </a:extLst>
-          </p:cNvPr>
-          <p:cNvSpPr/>
-          <p:nvPr/>
-        </p:nvSpPr>
-        <p:spPr>
-          <a:xfrm>
-            <a:off x="5001768" y="1757172"/>
-            <a:ext cx="3566160" cy="219456"/>
-          </a:xfrm>
-          <a:prstGeom prst="rect">
-            <a:avLst/>
-          </a:prstGeom>
-          <a:noFill/>
-          <a:ln/>
-        </p:spPr>
-        <p:txBody>
-          <a:bodyPr wrap="square" lIns="0" tIns="0" rIns="0" bIns="0" rtlCol="0" anchor="ctr"/>
-          <a:lstStyle/>
-          <a:p>
-            <a:pPr marL="0" indent="0">
-              <a:buNone/>
-            </a:pPr>
-            <a:r>
-              <a:rPr lang="en-US" sz="1100" dirty="0">
-                <a:latin typeface="Calibri" pitchFamily="34" charset="0"/>
-                <a:ea typeface="Calibri" pitchFamily="34" charset="-122"/>
-                <a:cs typeface="Calibri" pitchFamily="34" charset="-120"/>
-              </a:rPr>
-              <a:t>Across 8 cities in Cameroon</a:t>
-            </a:r>
-            <a:endParaRPr lang="en-US" sz="1100" dirty="0"/>
-          </a:p>
-        </p:txBody>
-      </p:sp>
-      <p:sp>
-        <p:nvSpPr>
-          <p:cNvPr id="38" name="Shape 37">
-            <a:extLst>
-              <a:ext uri="{FF2B5EF4-FFF2-40B4-BE49-F238E27FC236}">
-                <a16:creationId xmlns:a16="http://schemas.microsoft.com/office/drawing/2014/main" id="{442432AE-7E67-B8D7-C490-C14F73EC5EBB}"/>
-              </a:ext>
-            </a:extLst>
-          </p:cNvPr>
-          <p:cNvSpPr/>
-          <p:nvPr/>
-        </p:nvSpPr>
-        <p:spPr>
-          <a:xfrm>
-            <a:off x="4846320" y="2122932"/>
-            <a:ext cx="3840480" cy="713232"/>
-          </a:xfrm>
-          <a:prstGeom prst="rect">
-            <a:avLst/>
-          </a:prstGeom>
-          <a:solidFill>
-            <a:srgbClr val="FAFEFF"/>
-          </a:solidFill>
-          <a:ln w="6350">
-            <a:solidFill>
-              <a:srgbClr val="BBDEFB"/>
-            </a:solidFill>
-            <a:prstDash val="solid"/>
-          </a:ln>
-          <a:effectLst>
-            <a:outerShdw blurRad="50800" dist="25400" dir="8100000" algn="bl" rotWithShape="0">
-              <a:srgbClr val="000000">
-                <a:alpha val="6000"/>
-              </a:srgbClr>
-            </a:outerShdw>
-          </a:effectLst>
-        </p:spPr>
-      </p:sp>
-      <p:sp>
-        <p:nvSpPr>
-          <p:cNvPr id="39" name="Shape 38">
-            <a:extLst>
-              <a:ext uri="{FF2B5EF4-FFF2-40B4-BE49-F238E27FC236}">
-                <a16:creationId xmlns:a16="http://schemas.microsoft.com/office/drawing/2014/main" id="{D6EDEC08-2524-A229-A4B4-09520144C694}"/>
-              </a:ext>
-            </a:extLst>
-          </p:cNvPr>
-          <p:cNvSpPr/>
-          <p:nvPr/>
-        </p:nvSpPr>
-        <p:spPr>
-          <a:xfrm>
-            <a:off x="4846320" y="2122932"/>
-            <a:ext cx="64008" cy="713232"/>
-          </a:xfrm>
-          <a:prstGeom prst="rect">
-            <a:avLst/>
-          </a:prstGeom>
-          <a:solidFill>
-            <a:srgbClr val="1565C0"/>
-          </a:solidFill>
-          <a:ln w="12700">
-            <a:solidFill>
-              <a:srgbClr val="1565C0"/>
-            </a:solidFill>
-            <a:prstDash val="solid"/>
-          </a:ln>
-        </p:spPr>
-      </p:sp>
-      <p:sp>
-        <p:nvSpPr>
-          <p:cNvPr id="40" name="Text 39">
-            <a:extLst>
-              <a:ext uri="{FF2B5EF4-FFF2-40B4-BE49-F238E27FC236}">
-                <a16:creationId xmlns:a16="http://schemas.microsoft.com/office/drawing/2014/main" id="{5CE2DAD8-55CD-2F69-A9D6-78D3DC9F3FB1}"/>
-              </a:ext>
-            </a:extLst>
-          </p:cNvPr>
-          <p:cNvSpPr/>
-          <p:nvPr/>
-        </p:nvSpPr>
-        <p:spPr>
-          <a:xfrm>
-            <a:off x="5001768" y="2196084"/>
-            <a:ext cx="1280160" cy="365760"/>
-          </a:xfrm>
-          <a:prstGeom prst="rect">
-            <a:avLst/>
-          </a:prstGeom>
-          <a:noFill/>
-          <a:ln/>
-        </p:spPr>
-        <p:txBody>
-          <a:bodyPr wrap="square" lIns="0" tIns="0" rIns="0" bIns="0" rtlCol="0" anchor="ctr"/>
-          <a:lstStyle/>
-          <a:p>
-            <a:pPr marL="0" indent="0">
-              <a:buNone/>
-            </a:pPr>
-            <a:r>
-              <a:rPr lang="en-US" sz="3600" b="1" dirty="0">
-                <a:solidFill>
-                  <a:srgbClr val="1565C0"/>
-                </a:solidFill>
-                <a:latin typeface="Calibri" pitchFamily="34" charset="0"/>
-                <a:ea typeface="Calibri" pitchFamily="34" charset="-122"/>
-                <a:cs typeface="Calibri" pitchFamily="34" charset="-120"/>
-              </a:rPr>
-              <a:t>32</a:t>
-            </a:r>
-            <a:endParaRPr lang="en-US" sz="3600" dirty="0"/>
-          </a:p>
-        </p:txBody>
-      </p:sp>
-      <p:sp>
-        <p:nvSpPr>
-          <p:cNvPr id="41" name="Text 40">
-            <a:extLst>
-              <a:ext uri="{FF2B5EF4-FFF2-40B4-BE49-F238E27FC236}">
-                <a16:creationId xmlns:a16="http://schemas.microsoft.com/office/drawing/2014/main" id="{6EB3B0D9-42F8-0695-AAFB-89DA32B33A46}"/>
-              </a:ext>
-            </a:extLst>
-          </p:cNvPr>
-          <p:cNvSpPr/>
-          <p:nvPr/>
-        </p:nvSpPr>
-        <p:spPr>
-          <a:xfrm>
-            <a:off x="6336792" y="2214372"/>
-            <a:ext cx="2240280" cy="256032"/>
-          </a:xfrm>
-          <a:prstGeom prst="rect">
-            <a:avLst/>
-          </a:prstGeom>
-          <a:noFill/>
-          <a:ln/>
-        </p:spPr>
-        <p:txBody>
-          <a:bodyPr wrap="square" lIns="0" tIns="0" rIns="0" bIns="0" rtlCol="0" anchor="ctr"/>
-          <a:lstStyle/>
-          <a:p>
-            <a:pPr marL="0" indent="0">
-              <a:buNone/>
-            </a:pPr>
-            <a:r>
-              <a:rPr lang="en-US" sz="1600" b="1" dirty="0">
-                <a:solidFill>
-                  <a:srgbClr val="0A2342"/>
-                </a:solidFill>
-                <a:latin typeface="Calibri" pitchFamily="34" charset="0"/>
-                <a:ea typeface="Calibri" pitchFamily="34" charset="-122"/>
-                <a:cs typeface="Calibri" pitchFamily="34" charset="-120"/>
-              </a:rPr>
-              <a:t>Requirements Documented</a:t>
-            </a:r>
-            <a:endParaRPr lang="en-US" sz="1600" dirty="0"/>
-          </a:p>
-        </p:txBody>
-      </p:sp>
-      <p:sp>
-        <p:nvSpPr>
-          <p:cNvPr id="42" name="Text 41">
-            <a:extLst>
-              <a:ext uri="{FF2B5EF4-FFF2-40B4-BE49-F238E27FC236}">
-                <a16:creationId xmlns:a16="http://schemas.microsoft.com/office/drawing/2014/main" id="{0C6E2094-2FA9-8DCC-6EE9-142F157A9E64}"/>
-              </a:ext>
-            </a:extLst>
-          </p:cNvPr>
-          <p:cNvSpPr/>
-          <p:nvPr/>
-        </p:nvSpPr>
-        <p:spPr>
-          <a:xfrm>
-            <a:off x="5001768" y="2580132"/>
-            <a:ext cx="3566160" cy="219456"/>
-          </a:xfrm>
-          <a:prstGeom prst="rect">
-            <a:avLst/>
-          </a:prstGeom>
-          <a:noFill/>
-          <a:ln/>
-        </p:spPr>
-        <p:txBody>
-          <a:bodyPr wrap="square" lIns="0" tIns="0" rIns="0" bIns="0" rtlCol="0" anchor="ctr"/>
-          <a:lstStyle/>
-          <a:p>
-            <a:pPr marL="0" indent="0">
-              <a:buNone/>
-            </a:pPr>
-            <a:r>
-              <a:rPr lang="en-US" sz="1100" dirty="0">
-                <a:latin typeface="Calibri" pitchFamily="34" charset="0"/>
-                <a:ea typeface="Calibri" pitchFamily="34" charset="-122"/>
-                <a:cs typeface="Calibri" pitchFamily="34" charset="-120"/>
-              </a:rPr>
-              <a:t>20 FR + 20 NFR in SRS</a:t>
-            </a:r>
-            <a:endParaRPr lang="en-US" sz="1100" dirty="0"/>
-          </a:p>
-        </p:txBody>
-      </p:sp>
-      <p:sp>
-        <p:nvSpPr>
-          <p:cNvPr id="43" name="Shape 42">
-            <a:extLst>
-              <a:ext uri="{FF2B5EF4-FFF2-40B4-BE49-F238E27FC236}">
-                <a16:creationId xmlns:a16="http://schemas.microsoft.com/office/drawing/2014/main" id="{5A2A5FD7-1B8F-3371-3B95-C5BFC344606A}"/>
-              </a:ext>
-            </a:extLst>
-          </p:cNvPr>
-          <p:cNvSpPr/>
-          <p:nvPr/>
-        </p:nvSpPr>
-        <p:spPr>
-          <a:xfrm>
-            <a:off x="4846320" y="2945892"/>
-            <a:ext cx="3840480" cy="713232"/>
-          </a:xfrm>
-          <a:prstGeom prst="rect">
-            <a:avLst/>
-          </a:prstGeom>
-          <a:solidFill>
-            <a:srgbClr val="FAFEFF"/>
-          </a:solidFill>
-          <a:ln w="6350">
-            <a:solidFill>
-              <a:srgbClr val="BBDEFB"/>
-            </a:solidFill>
-            <a:prstDash val="solid"/>
-          </a:ln>
-          <a:effectLst>
-            <a:outerShdw blurRad="50800" dist="25400" dir="8100000" algn="bl" rotWithShape="0">
-              <a:srgbClr val="000000">
-                <a:alpha val="6000"/>
-              </a:srgbClr>
-            </a:outerShdw>
-          </a:effectLst>
-        </p:spPr>
-      </p:sp>
-      <p:sp>
-        <p:nvSpPr>
-          <p:cNvPr id="44" name="Shape 43">
-            <a:extLst>
-              <a:ext uri="{FF2B5EF4-FFF2-40B4-BE49-F238E27FC236}">
-                <a16:creationId xmlns:a16="http://schemas.microsoft.com/office/drawing/2014/main" id="{66CEDE6F-2140-8E57-9880-8D7250BD62C4}"/>
-              </a:ext>
-            </a:extLst>
-          </p:cNvPr>
-          <p:cNvSpPr/>
-          <p:nvPr/>
-        </p:nvSpPr>
-        <p:spPr>
-          <a:xfrm>
-            <a:off x="4846320" y="2945892"/>
-            <a:ext cx="64008" cy="713232"/>
-          </a:xfrm>
-          <a:prstGeom prst="rect">
-            <a:avLst/>
-          </a:prstGeom>
-          <a:solidFill>
-            <a:srgbClr val="7B1FA2"/>
-          </a:solidFill>
-          <a:ln w="12700">
-            <a:solidFill>
-              <a:srgbClr val="7B1FA2"/>
-            </a:solidFill>
-            <a:prstDash val="solid"/>
-          </a:ln>
-        </p:spPr>
-      </p:sp>
-      <p:sp>
-        <p:nvSpPr>
-          <p:cNvPr id="45" name="Text 44">
-            <a:extLst>
-              <a:ext uri="{FF2B5EF4-FFF2-40B4-BE49-F238E27FC236}">
-                <a16:creationId xmlns:a16="http://schemas.microsoft.com/office/drawing/2014/main" id="{FE59EE83-4C45-5E47-3906-8F4A3EEBA505}"/>
-              </a:ext>
-            </a:extLst>
-          </p:cNvPr>
-          <p:cNvSpPr/>
-          <p:nvPr/>
-        </p:nvSpPr>
-        <p:spPr>
-          <a:xfrm>
-            <a:off x="5001768" y="3019044"/>
-            <a:ext cx="1280160" cy="365760"/>
-          </a:xfrm>
-          <a:prstGeom prst="rect">
-            <a:avLst/>
-          </a:prstGeom>
-          <a:noFill/>
-          <a:ln/>
-        </p:spPr>
-        <p:txBody>
-          <a:bodyPr wrap="square" lIns="0" tIns="0" rIns="0" bIns="0" rtlCol="0" anchor="ctr"/>
-          <a:lstStyle/>
-          <a:p>
-            <a:pPr marL="0" indent="0">
-              <a:buNone/>
-            </a:pPr>
-            <a:r>
-              <a:rPr lang="en-US" sz="3600" b="1" dirty="0">
-                <a:solidFill>
-                  <a:srgbClr val="7B1FA2"/>
-                </a:solidFill>
-                <a:latin typeface="Calibri" pitchFamily="34" charset="0"/>
-                <a:ea typeface="Calibri" pitchFamily="34" charset="-122"/>
-                <a:cs typeface="Calibri" pitchFamily="34" charset="-120"/>
-              </a:rPr>
-              <a:t>89.1%</a:t>
-            </a:r>
-            <a:endParaRPr lang="en-US" sz="3600" dirty="0"/>
-          </a:p>
-        </p:txBody>
-      </p:sp>
-      <p:sp>
-        <p:nvSpPr>
-          <p:cNvPr id="46" name="Text 45">
-            <a:extLst>
-              <a:ext uri="{FF2B5EF4-FFF2-40B4-BE49-F238E27FC236}">
-                <a16:creationId xmlns:a16="http://schemas.microsoft.com/office/drawing/2014/main" id="{1AB24235-0E76-39A6-9E64-EA055F72E9AC}"/>
-              </a:ext>
-            </a:extLst>
-          </p:cNvPr>
-          <p:cNvSpPr/>
-          <p:nvPr/>
-        </p:nvSpPr>
-        <p:spPr>
-          <a:xfrm>
-            <a:off x="6336792" y="3037332"/>
-            <a:ext cx="2240280" cy="256032"/>
-          </a:xfrm>
-          <a:prstGeom prst="rect">
-            <a:avLst/>
-          </a:prstGeom>
-          <a:noFill/>
-          <a:ln/>
-        </p:spPr>
-        <p:txBody>
-          <a:bodyPr wrap="square" lIns="0" tIns="0" rIns="0" bIns="0" rtlCol="0" anchor="ctr"/>
-          <a:lstStyle/>
-          <a:p>
-            <a:pPr marL="0" indent="0">
-              <a:buNone/>
-            </a:pPr>
-            <a:r>
-              <a:rPr lang="en-US" sz="1600" b="1" dirty="0">
-                <a:solidFill>
-                  <a:srgbClr val="0A2342"/>
-                </a:solidFill>
-                <a:latin typeface="Calibri" pitchFamily="34" charset="0"/>
-                <a:ea typeface="Calibri" pitchFamily="34" charset="-122"/>
-                <a:cs typeface="Calibri" pitchFamily="34" charset="-120"/>
-              </a:rPr>
-              <a:t>Primary Pain Point</a:t>
-            </a:r>
-            <a:endParaRPr lang="en-US" sz="1600" dirty="0"/>
-          </a:p>
-        </p:txBody>
-      </p:sp>
-      <p:sp>
-        <p:nvSpPr>
-          <p:cNvPr id="47" name="Text 46">
-            <a:extLst>
-              <a:ext uri="{FF2B5EF4-FFF2-40B4-BE49-F238E27FC236}">
-                <a16:creationId xmlns:a16="http://schemas.microsoft.com/office/drawing/2014/main" id="{2F8367CF-3B7E-9455-8183-70198538B0E6}"/>
-              </a:ext>
-            </a:extLst>
-          </p:cNvPr>
-          <p:cNvSpPr/>
-          <p:nvPr/>
-        </p:nvSpPr>
-        <p:spPr>
-          <a:xfrm>
-            <a:off x="5001768" y="3403092"/>
-            <a:ext cx="3566160" cy="219456"/>
-          </a:xfrm>
-          <a:prstGeom prst="rect">
-            <a:avLst/>
-          </a:prstGeom>
-          <a:noFill/>
-          <a:ln/>
-        </p:spPr>
-        <p:txBody>
-          <a:bodyPr wrap="square" lIns="0" tIns="0" rIns="0" bIns="0" rtlCol="0" anchor="ctr"/>
-          <a:lstStyle/>
-          <a:p>
-            <a:pPr marL="0" indent="0">
-              <a:buNone/>
-            </a:pPr>
-            <a:r>
-              <a:rPr lang="en-US" sz="1100" dirty="0">
-                <a:latin typeface="Calibri" pitchFamily="34" charset="0"/>
-                <a:ea typeface="Calibri" pitchFamily="34" charset="-122"/>
-                <a:cs typeface="Calibri" pitchFamily="34" charset="-120"/>
-              </a:rPr>
-              <a:t>Cite slow internet / buffering</a:t>
-            </a:r>
-            <a:endParaRPr lang="en-US" sz="1100" dirty="0"/>
-          </a:p>
-        </p:txBody>
-      </p:sp>
-      <p:sp>
-        <p:nvSpPr>
-          <p:cNvPr id="48" name="Shape 47">
-            <a:extLst>
-              <a:ext uri="{FF2B5EF4-FFF2-40B4-BE49-F238E27FC236}">
-                <a16:creationId xmlns:a16="http://schemas.microsoft.com/office/drawing/2014/main" id="{3489E568-7E13-997A-0F17-3921FD7FA7C3}"/>
-              </a:ext>
-            </a:extLst>
-          </p:cNvPr>
-          <p:cNvSpPr/>
-          <p:nvPr/>
-        </p:nvSpPr>
-        <p:spPr>
-          <a:xfrm>
-            <a:off x="4846320" y="3768852"/>
-            <a:ext cx="3840480" cy="713232"/>
-          </a:xfrm>
-          <a:prstGeom prst="rect">
-            <a:avLst/>
-          </a:prstGeom>
-          <a:solidFill>
-            <a:srgbClr val="FAFEFF"/>
-          </a:solidFill>
-          <a:ln w="6350">
-            <a:solidFill>
-              <a:srgbClr val="BBDEFB"/>
-            </a:solidFill>
-            <a:prstDash val="solid"/>
-          </a:ln>
-          <a:effectLst>
-            <a:outerShdw blurRad="50800" dist="25400" dir="8100000" algn="bl" rotWithShape="0">
-              <a:srgbClr val="000000">
-                <a:alpha val="6000"/>
-              </a:srgbClr>
-            </a:outerShdw>
-          </a:effectLst>
-        </p:spPr>
-      </p:sp>
-      <p:sp>
-        <p:nvSpPr>
-          <p:cNvPr id="49" name="Shape 48">
-            <a:extLst>
-              <a:ext uri="{FF2B5EF4-FFF2-40B4-BE49-F238E27FC236}">
-                <a16:creationId xmlns:a16="http://schemas.microsoft.com/office/drawing/2014/main" id="{D0AE5B9D-E5ED-9421-74FA-3C2BC33283C5}"/>
-              </a:ext>
-            </a:extLst>
-          </p:cNvPr>
-          <p:cNvSpPr/>
-          <p:nvPr/>
-        </p:nvSpPr>
-        <p:spPr>
-          <a:xfrm>
-            <a:off x="4846320" y="3768852"/>
-            <a:ext cx="64008" cy="713232"/>
-          </a:xfrm>
-          <a:prstGeom prst="rect">
-            <a:avLst/>
-          </a:prstGeom>
-          <a:solidFill>
-            <a:srgbClr val="1B5E20"/>
-          </a:solidFill>
-          <a:ln w="12700">
-            <a:solidFill>
-              <a:srgbClr val="1B5E20"/>
-            </a:solidFill>
-            <a:prstDash val="solid"/>
-          </a:ln>
-        </p:spPr>
-      </p:sp>
-      <p:sp>
-        <p:nvSpPr>
-          <p:cNvPr id="50" name="Text 49">
-            <a:extLst>
-              <a:ext uri="{FF2B5EF4-FFF2-40B4-BE49-F238E27FC236}">
-                <a16:creationId xmlns:a16="http://schemas.microsoft.com/office/drawing/2014/main" id="{D78F17AD-1FFF-A818-695E-313090507B6D}"/>
-              </a:ext>
-            </a:extLst>
-          </p:cNvPr>
-          <p:cNvSpPr/>
-          <p:nvPr/>
-        </p:nvSpPr>
-        <p:spPr>
-          <a:xfrm>
-            <a:off x="5001768" y="3842004"/>
-            <a:ext cx="1280160" cy="365760"/>
-          </a:xfrm>
-          <a:prstGeom prst="rect">
-            <a:avLst/>
-          </a:prstGeom>
-          <a:noFill/>
-          <a:ln/>
-        </p:spPr>
-        <p:txBody>
-          <a:bodyPr wrap="square" lIns="0" tIns="0" rIns="0" bIns="0" rtlCol="0" anchor="ctr"/>
-          <a:lstStyle/>
-          <a:p>
-            <a:pPr marL="0" indent="0">
-              <a:buNone/>
-            </a:pPr>
-            <a:r>
-              <a:rPr lang="en-US" sz="3600" b="1" dirty="0">
-                <a:solidFill>
-                  <a:srgbClr val="1B5E20"/>
-                </a:solidFill>
-                <a:latin typeface="Calibri" pitchFamily="34" charset="0"/>
-                <a:ea typeface="Calibri" pitchFamily="34" charset="-122"/>
-                <a:cs typeface="Calibri" pitchFamily="34" charset="-120"/>
-              </a:rPr>
-              <a:t>87.8%</a:t>
-            </a:r>
-            <a:endParaRPr lang="en-US" sz="3600" dirty="0"/>
-          </a:p>
-        </p:txBody>
-      </p:sp>
-      <p:sp>
-        <p:nvSpPr>
-          <p:cNvPr id="51" name="Text 50">
-            <a:extLst>
-              <a:ext uri="{FF2B5EF4-FFF2-40B4-BE49-F238E27FC236}">
-                <a16:creationId xmlns:a16="http://schemas.microsoft.com/office/drawing/2014/main" id="{AF3D18A2-8C49-038F-19CC-F8C7B294E58B}"/>
-              </a:ext>
-            </a:extLst>
-          </p:cNvPr>
-          <p:cNvSpPr/>
-          <p:nvPr/>
-        </p:nvSpPr>
-        <p:spPr>
-          <a:xfrm>
-            <a:off x="6336792" y="3860292"/>
-            <a:ext cx="2240280" cy="256032"/>
-          </a:xfrm>
-          <a:prstGeom prst="rect">
-            <a:avLst/>
-          </a:prstGeom>
-          <a:noFill/>
-          <a:ln/>
-        </p:spPr>
-        <p:txBody>
-          <a:bodyPr wrap="square" lIns="0" tIns="0" rIns="0" bIns="0" rtlCol="0" anchor="ctr"/>
-          <a:lstStyle/>
-          <a:p>
-            <a:pPr marL="0" indent="0">
-              <a:buNone/>
-            </a:pPr>
-            <a:r>
-              <a:rPr lang="en-US" sz="1600" b="1" dirty="0">
-                <a:solidFill>
-                  <a:srgbClr val="0A2342"/>
-                </a:solidFill>
-                <a:latin typeface="Calibri" pitchFamily="34" charset="0"/>
-                <a:ea typeface="Calibri" pitchFamily="34" charset="-122"/>
-                <a:cs typeface="Calibri" pitchFamily="34" charset="-120"/>
-              </a:rPr>
-              <a:t>Conditional App Adoption</a:t>
-            </a:r>
-            <a:endParaRPr lang="en-US" sz="1600" dirty="0"/>
-          </a:p>
-        </p:txBody>
-      </p:sp>
-      <p:sp>
-        <p:nvSpPr>
-          <p:cNvPr id="52" name="Text 51">
-            <a:extLst>
-              <a:ext uri="{FF2B5EF4-FFF2-40B4-BE49-F238E27FC236}">
-                <a16:creationId xmlns:a16="http://schemas.microsoft.com/office/drawing/2014/main" id="{EDAD01B9-5BAB-F677-8D66-7B41802C86DF}"/>
-              </a:ext>
-            </a:extLst>
-          </p:cNvPr>
-          <p:cNvSpPr/>
-          <p:nvPr/>
-        </p:nvSpPr>
-        <p:spPr>
-          <a:xfrm>
-            <a:off x="5001768" y="4226052"/>
-            <a:ext cx="3566160" cy="219456"/>
-          </a:xfrm>
-          <a:prstGeom prst="rect">
-            <a:avLst/>
-          </a:prstGeom>
-          <a:noFill/>
-          <a:ln/>
-        </p:spPr>
-        <p:txBody>
-          <a:bodyPr wrap="square" lIns="0" tIns="0" rIns="0" bIns="0" rtlCol="0" anchor="ctr"/>
-          <a:lstStyle/>
-          <a:p>
-            <a:pPr marL="0" indent="0">
-              <a:buNone/>
-            </a:pPr>
-            <a:r>
-              <a:rPr lang="en-US" sz="1100" dirty="0">
-                <a:latin typeface="Calibri" pitchFamily="34" charset="0"/>
-                <a:ea typeface="Calibri" pitchFamily="34" charset="-122"/>
-                <a:cs typeface="Calibri" pitchFamily="34" charset="-120"/>
-              </a:rPr>
-              <a:t>Would install if performance meets expectations</a:t>
-            </a:r>
-            <a:endParaRPr lang="en-US" sz="1100" dirty="0"/>
           </a:p>
         </p:txBody>
       </p:sp>
@@ -13883,6 +12730,178 @@
               <a:t>1</a:t>
             </a:r>
             <a:endParaRPr lang="en-CM" b="1" dirty="0"/>
+          </a:p>
+        </p:txBody>
+      </p:sp>
+      <p:sp>
+        <p:nvSpPr>
+          <p:cNvPr id="54" name="TextBox 53">
+            <a:extLst>
+              <a:ext uri="{FF2B5EF4-FFF2-40B4-BE49-F238E27FC236}">
+                <a16:creationId xmlns:a16="http://schemas.microsoft.com/office/drawing/2014/main" id="{C09AF940-C65B-B098-F7C9-486E6E36E2F6}"/>
+              </a:ext>
+            </a:extLst>
+          </p:cNvPr>
+          <p:cNvSpPr txBox="1"/>
+          <p:nvPr/>
+        </p:nvSpPr>
+        <p:spPr>
+          <a:xfrm>
+            <a:off x="457200" y="767443"/>
+            <a:ext cx="3886200" cy="400110"/>
+          </a:xfrm>
+          <a:prstGeom prst="rect">
+            <a:avLst/>
+          </a:prstGeom>
+          <a:noFill/>
+        </p:spPr>
+        <p:txBody>
+          <a:bodyPr wrap="square" rtlCol="0">
+            <a:spAutoFit/>
+          </a:bodyPr>
+          <a:lstStyle/>
+          <a:p>
+            <a:r>
+              <a:rPr lang="fr-FR" sz="2000" b="1" dirty="0" err="1"/>
+              <a:t>What</a:t>
+            </a:r>
+            <a:r>
+              <a:rPr lang="fr-FR" sz="2000" b="1" dirty="0"/>
+              <a:t> </a:t>
+            </a:r>
+            <a:r>
+              <a:rPr lang="fr-FR" sz="2000" b="1" dirty="0" err="1"/>
+              <a:t>is</a:t>
+            </a:r>
+            <a:r>
+              <a:rPr lang="fr-FR" sz="2000" b="1" dirty="0"/>
+              <a:t> </a:t>
+            </a:r>
+            <a:r>
+              <a:rPr lang="fr-FR" sz="2000" b="1" dirty="0" err="1"/>
+              <a:t>Requirements</a:t>
+            </a:r>
+            <a:r>
+              <a:rPr lang="fr-FR" sz="2000" b="1" dirty="0"/>
+              <a:t> </a:t>
+            </a:r>
+            <a:r>
+              <a:rPr lang="fr-FR" sz="2000" b="1" dirty="0" err="1"/>
+              <a:t>Analysis</a:t>
+            </a:r>
+            <a:r>
+              <a:rPr lang="fr-FR" sz="2000" b="1" dirty="0"/>
+              <a:t>?</a:t>
+            </a:r>
+            <a:endParaRPr lang="en-CM" sz="2000" b="1" dirty="0"/>
+          </a:p>
+        </p:txBody>
+      </p:sp>
+      <p:sp>
+        <p:nvSpPr>
+          <p:cNvPr id="55" name="TextBox 54">
+            <a:extLst>
+              <a:ext uri="{FF2B5EF4-FFF2-40B4-BE49-F238E27FC236}">
+                <a16:creationId xmlns:a16="http://schemas.microsoft.com/office/drawing/2014/main" id="{F7837DB5-3D77-29D8-718E-78A2CA617103}"/>
+              </a:ext>
+            </a:extLst>
+          </p:cNvPr>
+          <p:cNvSpPr txBox="1"/>
+          <p:nvPr/>
+        </p:nvSpPr>
+        <p:spPr>
+          <a:xfrm>
+            <a:off x="457200" y="1200210"/>
+            <a:ext cx="8352065" cy="584775"/>
+          </a:xfrm>
+          <a:prstGeom prst="rect">
+            <a:avLst/>
+          </a:prstGeom>
+          <a:noFill/>
+        </p:spPr>
+        <p:txBody>
+          <a:bodyPr wrap="square" rtlCol="0">
+            <a:spAutoFit/>
+          </a:bodyPr>
+          <a:lstStyle/>
+          <a:p>
+            <a:r>
+              <a:rPr lang="fr-FR" sz="1600" dirty="0"/>
+              <a:t>It </a:t>
+            </a:r>
+            <a:r>
+              <a:rPr lang="fr-FR" sz="1600" dirty="0" err="1"/>
+              <a:t>is</a:t>
+            </a:r>
+            <a:r>
+              <a:rPr lang="fr-FR" sz="1600" dirty="0"/>
+              <a:t> the process of </a:t>
+            </a:r>
+            <a:r>
+              <a:rPr lang="fr-FR" sz="1600" dirty="0" err="1"/>
+              <a:t>figuring</a:t>
+            </a:r>
+            <a:r>
+              <a:rPr lang="fr-FR" sz="1600" dirty="0"/>
+              <a:t> out </a:t>
+            </a:r>
+            <a:r>
+              <a:rPr lang="fr-FR" sz="1600" dirty="0" err="1"/>
+              <a:t>exactly</a:t>
+            </a:r>
+            <a:r>
+              <a:rPr lang="fr-FR" sz="1600" dirty="0"/>
+              <a:t> </a:t>
+            </a:r>
+            <a:r>
+              <a:rPr lang="fr-FR" sz="1600" dirty="0" err="1"/>
+              <a:t>what</a:t>
+            </a:r>
+            <a:r>
+              <a:rPr lang="fr-FR" sz="1600" dirty="0"/>
+              <a:t> </a:t>
+            </a:r>
+            <a:r>
+              <a:rPr lang="fr-FR" sz="1600" dirty="0" err="1"/>
+              <a:t>customers</a:t>
+            </a:r>
+            <a:r>
+              <a:rPr lang="fr-FR" sz="1600" dirty="0"/>
+              <a:t> or </a:t>
+            </a:r>
+            <a:r>
+              <a:rPr lang="fr-FR" sz="1600" dirty="0" err="1"/>
+              <a:t>users</a:t>
+            </a:r>
+            <a:r>
+              <a:rPr lang="fr-FR" sz="1600" dirty="0"/>
+              <a:t> </a:t>
+            </a:r>
+            <a:r>
+              <a:rPr lang="fr-FR" sz="1600" dirty="0" err="1"/>
+              <a:t>need</a:t>
+            </a:r>
+            <a:r>
+              <a:rPr lang="fr-FR" sz="1600" dirty="0"/>
+              <a:t> the system or software to do </a:t>
+            </a:r>
+            <a:r>
+              <a:rPr lang="fr-FR" sz="1600" dirty="0" err="1"/>
+              <a:t>before</a:t>
+            </a:r>
+            <a:r>
+              <a:rPr lang="fr-FR" sz="1600" dirty="0"/>
+              <a:t> building </a:t>
+            </a:r>
+            <a:r>
+              <a:rPr lang="fr-FR" sz="1600" dirty="0" err="1"/>
+              <a:t>it</a:t>
+            </a:r>
+            <a:r>
+              <a:rPr lang="fr-FR" sz="1600" dirty="0"/>
+              <a:t>.</a:t>
+            </a:r>
+            <a:endParaRPr lang="en-CM" sz="1600" dirty="0"/>
           </a:p>
         </p:txBody>
       </p:sp>
@@ -14160,7 +13179,9 @@
     <p:bg>
       <p:bgPr>
         <a:solidFill>
-          <a:srgbClr val="FFFFFF"/>
+          <a:schemeClr val="bg1">
+            <a:lumMod val="85000"/>
+          </a:schemeClr>
         </a:solidFill>
         <a:effectLst/>
       </p:bgPr>
@@ -14832,7 +13853,7 @@
         </p:nvSpPr>
         <p:spPr>
           <a:xfrm>
-            <a:off x="2560320" y="3259836"/>
+            <a:off x="2575016" y="3287230"/>
             <a:ext cx="1920240" cy="164592"/>
           </a:xfrm>
           <a:prstGeom prst="rect">
@@ -15677,7 +14698,9 @@
     <p:bg>
       <p:bgPr>
         <a:solidFill>
-          <a:srgbClr val="FFFFFF"/>
+          <a:schemeClr val="bg1">
+            <a:lumMod val="85000"/>
+          </a:schemeClr>
         </a:solidFill>
         <a:effectLst/>
       </p:bgPr>
@@ -15768,7 +14791,7 @@
         </p:nvSpPr>
         <p:spPr>
           <a:xfrm>
-            <a:off x="457200" y="777240"/>
+            <a:off x="457200" y="914400"/>
             <a:ext cx="3931920" cy="274320"/>
           </a:xfrm>
           <a:prstGeom prst="rect">
@@ -15804,8 +14827,8 @@
         </p:nvSpPr>
         <p:spPr>
           <a:xfrm>
-            <a:off x="457200" y="1051560"/>
-            <a:ext cx="3931920" cy="2286000"/>
+            <a:off x="457200" y="1051559"/>
+            <a:ext cx="3931920" cy="2410097"/>
           </a:xfrm>
           <a:prstGeom prst="rect">
             <a:avLst/>
@@ -15917,31 +14940,10 @@
                 <a:ea typeface="Calibri" pitchFamily="34" charset="-122"/>
                 <a:cs typeface="Calibri" pitchFamily="34" charset="-120"/>
               </a:rPr>
-              <a:t>Desired Features ranked by respondents</a:t>
+              <a:t>Data Governance &amp; Notification Preferences</a:t>
             </a:r>
             <a:endParaRPr lang="en-US" sz="1400" dirty="0"/>
           </a:p>
-          <a:p>
-            <a:pPr marL="342900" indent="-342900">
-              <a:spcAft>
-                <a:spcPts val="400"/>
-              </a:spcAft>
-              <a:buSzPct val="100000"/>
-              <a:buChar char="•"/>
-            </a:pPr>
-            <a:r>
-              <a:rPr lang="en-US" sz="1400" dirty="0">
-                <a:solidFill>
-                  <a:srgbClr val="212121"/>
-                </a:solidFill>
-                <a:latin typeface="Calibri" pitchFamily="34" charset="0"/>
-                <a:ea typeface="Calibri" pitchFamily="34" charset="-122"/>
-                <a:cs typeface="Calibri" pitchFamily="34" charset="-120"/>
-              </a:rPr>
-              <a:t>Data Governance &amp; Notification Preferences</a:t>
-            </a:r>
-            <a:endParaRPr lang="en-US" sz="1400" dirty="0"/>
-          </a:p>
         </p:txBody>
       </p:sp>
       <p:sp>
@@ -15952,7 +14954,7 @@
         </p:nvSpPr>
         <p:spPr>
           <a:xfrm>
-            <a:off x="4663440" y="777240"/>
+            <a:off x="4663440" y="914400"/>
             <a:ext cx="4114800" cy="274320"/>
           </a:xfrm>
           <a:prstGeom prst="rect">
@@ -16105,24 +15107,6 @@
                 <a:cs typeface="Calibri" pitchFamily="34" charset="-120"/>
               </a:rPr>
               <a:t>Optional/approximate GPS with consent</a:t>
-            </a:r>
-            <a:endParaRPr lang="en-US" sz="1600" dirty="0"/>
-          </a:p>
-          <a:p>
-            <a:pPr marL="342900" indent="-342900">
-              <a:buSzPct val="100000"/>
-              <a:buChar char="•"/>
-            </a:pPr>
-            <a:r>
-              <a:rPr lang="en-US" sz="1600" dirty="0">
-                <a:solidFill>
-                  <a:srgbClr val="212121"/>
-                </a:solidFill>
-                <a:latin typeface="Calibri" pitchFamily="34" charset="0"/>
-                <a:ea typeface="Calibri" pitchFamily="34" charset="-122"/>
-                <a:cs typeface="Calibri" pitchFamily="34" charset="-120"/>
-              </a:rPr>
-              <a:t>Anonymized data sharing</a:t>
             </a:r>
             <a:endParaRPr lang="en-US" sz="1600" dirty="0"/>
           </a:p>
@@ -16417,7 +15401,9 @@
     <p:bg>
       <p:bgPr>
         <a:solidFill>
-          <a:srgbClr val="FFFFFF"/>
+          <a:schemeClr val="bg1">
+            <a:lumMod val="85000"/>
+          </a:schemeClr>
         </a:solidFill>
         <a:effectLst/>
       </p:bgPr>
@@ -17097,7 +16083,7 @@
           </a:solidFill>
           <a:ln w="10160">
             <a:solidFill>
-              <a:srgbClr val="0A2342"/>
+              <a:schemeClr val="accent3"/>
             </a:solidFill>
             <a:prstDash val="solid"/>
           </a:ln>
@@ -17117,7 +16103,11 @@
           <a:prstGeom prst="rect">
             <a:avLst/>
           </a:prstGeom>
-          <a:noFill/>
+          <a:solidFill>
+            <a:schemeClr val="accent3">
+              <a:lumMod val="75000"/>
+            </a:schemeClr>
+          </a:solidFill>
           <a:ln/>
         </p:spPr>
         <p:txBody>
@@ -17844,7 +16834,9 @@
     <p:bg>
       <p:bgPr>
         <a:solidFill>
-          <a:srgbClr val="FFFFFF"/>
+          <a:schemeClr val="bg1">
+            <a:lumMod val="85000"/>
+          </a:schemeClr>
         </a:solidFill>
         <a:effectLst/>
       </p:bgPr>
@@ -18823,7 +17815,9 @@
     <p:bg>
       <p:bgPr>
         <a:solidFill>
-          <a:srgbClr val="FFFFFF"/>
+          <a:schemeClr val="bg1">
+            <a:lumMod val="85000"/>
+          </a:schemeClr>
         </a:solidFill>
         <a:effectLst/>
       </p:bgPr>

</xml_diff>